<commit_message>
feat: rename DeckFM to Oz Radio (oz-radio)
Display name 'Oz Radio', technical id 'oz-radio' across UI, Teams manifest (v1.0.1, same id), backend, podcast intro card, AI-enablement decks, tests and docs. localStorage user id migrates from 'deckfm.userId'. New maintenance 'rebrand-decks' rebrands deck images in place (same deck ids, playlists kept); render --force and media-only purge for re-renders. Azure resources and URL unchanged.

Co-authored-by: Copilot App <223556219+Copilot@users.noreply.github.com>
Copilot-Session: 9d85d55c-b7a4-4682-a057-b94208dcb06e
</commit_message>
<xml_diff>
--- a/content/ai-enablement/ai-enablement-1-beginner.pptx
+++ b/content/ai-enablement/ai-enablement-1-beginner.pptx
@@ -4358,7 +4358,7 @@
                 </a:solidFill>
                 <a:latin typeface="Calibri"/>
               </a:rPr>
-              <a:t>DECKFM · AI ENABLEMENT SERIES · PART 1 OF 3</a:t>
+              <a:t>OZ RADIO · AI ENABLEMENT SERIES · PART 1 OF 3</a:t>
             </a:r>
           </a:p>
         </p:txBody>
@@ -5177,7 +5177,7 @@
                 </a:solidFill>
                 <a:latin typeface="Calibri"/>
               </a:rPr>
-              <a:t>DeckFM · AI enablement · Beginner</a:t>
+              <a:t>Oz Radio · AI enablement · Beginner</a:t>
             </a:r>
           </a:p>
         </p:txBody>
@@ -5932,7 +5932,7 @@
                 </a:solidFill>
                 <a:latin typeface="Calibri"/>
               </a:rPr>
-              <a:t>DeckFM · AI enablement · Beginner</a:t>
+              <a:t>Oz Radio · AI enablement · Beginner</a:t>
             </a:r>
           </a:p>
         </p:txBody>
@@ -6759,7 +6759,7 @@
                 </a:solidFill>
                 <a:latin typeface="Calibri"/>
               </a:rPr>
-              <a:t>DeckFM · AI enablement · Beginner</a:t>
+              <a:t>Oz Radio · AI enablement · Beginner</a:t>
             </a:r>
           </a:p>
         </p:txBody>
@@ -7658,7 +7658,7 @@
                 </a:solidFill>
                 <a:latin typeface="Calibri"/>
               </a:rPr>
-              <a:t>DeckFM · AI enablement · Beginner</a:t>
+              <a:t>Oz Radio · AI enablement · Beginner</a:t>
             </a:r>
           </a:p>
         </p:txBody>
@@ -8326,7 +8326,7 @@
                 </a:solidFill>
                 <a:latin typeface="Calibri"/>
               </a:rPr>
-              <a:t>DeckFM · AI enablement · Beginner</a:t>
+              <a:t>Oz Radio · AI enablement · Beginner</a:t>
             </a:r>
           </a:p>
         </p:txBody>
@@ -8995,7 +8995,7 @@
                 </a:solidFill>
                 <a:latin typeface="Calibri"/>
               </a:rPr>
-              <a:t>DeckFM · AI enablement · Beginner</a:t>
+              <a:t>Oz Radio · AI enablement · Beginner</a:t>
             </a:r>
           </a:p>
         </p:txBody>
@@ -9730,7 +9730,7 @@
                 </a:solidFill>
                 <a:latin typeface="Calibri"/>
               </a:rPr>
-              <a:t>DeckFM · AI enablement · Beginner</a:t>
+              <a:t>Oz Radio · AI enablement · Beginner</a:t>
             </a:r>
           </a:p>
         </p:txBody>
@@ -10721,7 +10721,7 @@
                 </a:solidFill>
                 <a:latin typeface="Calibri"/>
               </a:rPr>
-              <a:t>DeckFM · AI enablement · Beginner</a:t>
+              <a:t>Oz Radio · AI enablement · Beginner</a:t>
             </a:r>
           </a:p>
         </p:txBody>
@@ -11313,7 +11313,7 @@
                 </a:solidFill>
                 <a:latin typeface="Calibri"/>
               </a:rPr>
-              <a:t>DeckFM · AI enablement · Beginner</a:t>
+              <a:t>Oz Radio · AI enablement · Beginner</a:t>
             </a:r>
           </a:p>
         </p:txBody>
@@ -12076,7 +12076,7 @@
                 </a:solidFill>
                 <a:latin typeface="Calibri"/>
               </a:rPr>
-              <a:t>DeckFM · AI enablement · Beginner</a:t>
+              <a:t>Oz Radio · AI enablement · Beginner</a:t>
             </a:r>
           </a:p>
         </p:txBody>
@@ -12961,7 +12961,7 @@
                 </a:solidFill>
                 <a:latin typeface="Calibri"/>
               </a:rPr>
-              <a:t>DeckFM · AI enablement · Beginner</a:t>
+              <a:t>Oz Radio · AI enablement · Beginner</a:t>
             </a:r>
           </a:p>
         </p:txBody>
@@ -13541,7 +13541,7 @@
                 </a:solidFill>
                 <a:latin typeface="Calibri"/>
               </a:rPr>
-              <a:t>DeckFM · AI enablement · Beginner</a:t>
+              <a:t>Oz Radio · AI enablement · Beginner</a:t>
             </a:r>
           </a:p>
         </p:txBody>

</xml_diff>